<commit_message>
Run on Apple Silicon (M5 Pro) without Docker or admin rights; M5-only docs
- pgctl.sh: native Postgres 16 + pgvector from the pgserver wheel (Docker optional);
  recreate.sh, run_series.sh, run_answer_ablation.sh use it
- services.sh: start / stop / status / clean-start check
- scenarios.py: the 18-scenario catalogue as a repeatable test
- retrieve(): hnsw.ef_search fallback for pgvector without iterative scan
- ingest.py: Docling through .venv-docling; records the vision model
- pid_eval.py: names the machine and the real vision model
- Experiments: qwen3:8b escalate grader (unseen 80% -> 96%), qwen2.5vl:7b,
  llama3.1:8b; model profiles with measured memory
- Docs rewritten for the M5 Pro: SOP (pre-work to troubleshooting), runbook,
  recreate guide, new install guide, deck rebuilt from build_deck.js, site

Co-Authored-By: Claude Opus 5.5 <noreply@anthropic.com>
</commit_message>
<xml_diff>
--- a/docs/ragcap_deck.pptx
+++ b/docs/ragcap_deck.pptx
@@ -121,39 +121,39 @@
   <p:extLst>
     <p:ext uri="{521415D9-36F7-43E2-AB2F-B90AF26B5E84}">
       <p14:sectionLst xmlns:p14="http://schemas.microsoft.com/office/powerpoint/2010/main">
-        <p14:section name="Overview" id="{5be648c8-0741-e03a-190b-ee913429affa}">
+        <p14:section name="Overview" id="{35e826de-12ee-8f53-2348-7d7b8da9b615}">
           <p14:sldIdLst>
             <p14:sldId id="256"/>
             <p14:sldId id="257"/>
           </p14:sldIdLst>
         </p14:section>
-        <p14:section name="How it works" id="{1b9f7181-b94a-bc72-da40-14a0065aa4b7}">
+        <p14:section name="How it works" id="{3442120d-3bf7-c164-0305-3aa91107affa}">
           <p14:sldIdLst>
             <p14:sldId id="258"/>
             <p14:sldId id="259"/>
           </p14:sldIdLst>
         </p14:section>
-        <p14:section name="How it was built" id="{953ab2cf-15ec-149a-b9a2-ed4f5a405e7a}">
+        <p14:section name="How it is built" id="{85ceec96-cc9d-90d4-b62a-05633feddffe}">
           <p14:sldIdLst>
             <p14:sldId id="260"/>
             <p14:sldId id="261"/>
           </p14:sldIdLst>
         </p14:section>
-        <p14:section name="Results" id="{703c1590-a867-9ae5-347f-ba7bf632087a}">
+        <p14:section name="Results" id="{540ebe72-ffb6-3d4f-56a8-0ad39975362b}">
           <p14:sldIdLst>
             <p14:sldId id="262"/>
             <p14:sldId id="263"/>
             <p14:sldId id="264"/>
           </p14:sldIdLst>
         </p14:section>
-        <p14:section name="Showcase" id="{bbb8ed25-4c8f-f0f0-0485-7659cc06f211}">
+        <p14:section name="Showcase" id="{a3c1607e-a440-2837-32ab-93d5b9d58ed2}">
           <p14:sldIdLst>
             <p14:sldId id="265"/>
             <p14:sldId id="266"/>
             <p14:sldId id="267"/>
           </p14:sldIdLst>
         </p14:section>
-        <p14:section name="Deploy" id="{98cbbd0d-6ede-354d-2b59-60b820116b3c}">
+        <p14:section name="Deploy" id="{70f147b0-c54a-692d-404d-0c34970e05fe}">
           <p14:sldIdLst>
             <p14:sldId id="268"/>
             <p14:sldId id="269"/>
@@ -195,7 +195,7 @@
                 </a:solidFill>
                 <a:latin typeface="+mn-lt"/>
               </a:rPr>
-              <a:t>Percent (llama3.2:3b)</a:t>
+              <a:t>Percent, 3 runs each (llama3.2:3b)</a:t>
             </a:r>
           </a:p>
         </c:rich>
@@ -219,7 +219,7 @@
               <c:strCache>
                 <c:ptCount val="1"/>
                 <c:pt idx="0">
-                  <c:v>Tuned set (27, mean of 4 runs)</c:v>
+                  <c:v>Tuned set (27)</c:v>
                 </c:pt>
               </c:strCache>
             </c:strRef>
@@ -284,7 +284,7 @@
                   <c:v>100</c:v>
                 </c:pt>
                 <c:pt idx="1">
-                  <c:v>88.9</c:v>
+                  <c:v>92.6</c:v>
                 </c:pt>
                 <c:pt idx="2">
                   <c:v>100</c:v>
@@ -302,7 +302,7 @@
               <c:strCache>
                 <c:ptCount val="1"/>
                 <c:pt idx="0">
-                  <c:v>Unseen set (25, mean of 3 runs)</c:v>
+                  <c:v>Unseen set (25)</c:v>
                 </c:pt>
               </c:strCache>
             </c:strRef>
@@ -364,10 +364,93 @@
                 <c:formatCode>General</c:formatCode>
                 <c:ptCount val="3"/>
                 <c:pt idx="0">
-                  <c:v>96</c:v>
+                  <c:v>100</c:v>
                 </c:pt>
                 <c:pt idx="1">
-                  <c:v>81.3</c:v>
+                  <c:v>80</c:v>
+                </c:pt>
+                <c:pt idx="2">
+                  <c:v>100</c:v>
+                </c:pt>
+              </c:numCache>
+            </c:numRef>
+          </c:val>
+        </c:ser>
+        <c:ser>
+          <c:idx val="2"/>
+          <c:order val="2"/>
+          <c:tx>
+            <c:strRef>
+              <c:f>Sheet1!$D$1</c:f>
+              <c:strCache>
+                <c:ptCount val="1"/>
+                <c:pt idx="0">
+                  <c:v>Unseen, + qwen3:8b grader</c:v>
+                </c:pt>
+              </c:strCache>
+            </c:strRef>
+          </c:tx>
+          <c:spPr>
+            <a:solidFill>
+              <a:srgbClr val="1E7F4F"/>
+            </a:solidFill>
+            <a:effectLst/>
+          </c:spPr>
+          <c:invertIfNegative val="0"/>
+          <c:dLbls>
+            <c:numFmt formatCode="0.0" sourceLinked="0"/>
+            <c:txPr>
+              <a:bodyPr/>
+              <a:lstStyle/>
+              <a:p>
+                <a:pPr>
+                  <a:defRPr b="0" i="0" strike="noStrike" sz="1000" u="none">
+                    <a:solidFill>
+                      <a:srgbClr val="1F2933"/>
+                    </a:solidFill>
+                    <a:latin typeface="+mn-lt"/>
+                  </a:defRPr>
+                </a:pPr>
+              </a:p>
+            </c:txPr>
+            <c:showLegendKey val="0"/>
+            <c:showVal val="1"/>
+            <c:showCatName val="0"/>
+            <c:showSerName val="0"/>
+            <c:showPercent val="0"/>
+            <c:showBubbleSize val="0"/>
+            <c:showLeaderLines val="0"/>
+          </c:dLbls>
+          <c:cat>
+            <c:multiLvlStrRef>
+              <c:f>Sheet1!$A$2:$A$4</c:f>
+              <c:multiLvlStrCache>
+                <c:ptCount val="3"/>
+                <c:lvl>
+                  <c:pt idx="0">
+                    <c:v>Router accuracy</c:v>
+                  </c:pt>
+                  <c:pt idx="1">
+                    <c:v>Answers correct</c:v>
+                  </c:pt>
+                  <c:pt idx="2">
+                    <c:v>Retrieval hit rate</c:v>
+                  </c:pt>
+                </c:lvl>
+              </c:multiLvlStrCache>
+            </c:multiLvlStrRef>
+          </c:cat>
+          <c:val>
+            <c:numRef>
+              <c:f>Sheet1!$D$2:$D$4</c:f>
+              <c:numCache>
+                <c:formatCode>General</c:formatCode>
+                <c:ptCount val="3"/>
+                <c:pt idx="0">
+                  <c:v>100</c:v>
+                </c:pt>
+                <c:pt idx="1">
+                  <c:v>96</c:v>
                 </c:pt>
                 <c:pt idx="2">
                   <c:v>100</c:v>
@@ -1354,7 +1437,7 @@
           <a:p>
             <a:r>
               <a:rPr lang="en-US" dirty="0"/>
-              <a:t>Both screenshots are from real runs on the Mac; the latencies in the pills are real.</a:t>
+              <a:t>Both screenshots are from real runs on the M5 Pro; the latencies in the pills are real.</a:t>
             </a:r>
             <a:endParaRPr lang="en-US" dirty="0"/>
           </a:p>
@@ -1442,7 +1525,7 @@
           <a:p>
             <a:r>
               <a:rPr lang="en-US" dirty="0"/>
-              <a:t>This was the colleague's proposed direction. The scaffold and the measurement method transfer; the model needs to be bigger.</a:t>
+              <a:t>This was the colleague's proposed direction. The scaffold and the measurement method transfer; model size is not the next lever.</a:t>
             </a:r>
             <a:endParaRPr lang="en-US" dirty="0"/>
           </a:p>
@@ -2146,7 +2229,7 @@
           <a:p>
             <a:r>
               <a:rPr lang="en-US" dirty="0"/>
-              <a:t>Phase 4 is red on purpose: a recorded negative result is part of the method, not a failure of it.</a:t>
+              <a:t>These six stages are the sections of the SOP; each one can be done and checked on its own.</a:t>
             </a:r>
             <a:endParaRPr lang="en-US" dirty="0"/>
           </a:p>
@@ -2322,7 +2405,7 @@
           <a:p>
             <a:r>
               <a:rPr lang="en-US" dirty="0"/>
-              <a:t>Routing and retrieval generalise; answer accuracy drops 7.6 points on unseen questions, and the failing ids are the same every run, so they are model limits, not noise.</a:t>
+              <a:t>Routing and retrieval generalise to unseen questions; four of the five unseen failures are the small grader, which the second-opinion grader fixes.</a:t>
             </a:r>
             <a:endParaRPr lang="en-US" dirty="0"/>
           </a:p>
@@ -2410,7 +2493,7 @@
           <a:p>
             <a:r>
               <a:rPr lang="en-US" dirty="0"/>
-              <a:t>The headline is the left chart. The right table shows the control cases did not move and the cost is one millisecond.</a:t>
+              <a:t>The headline is the left chart. The right table shows the control cases did not move and the cost is at most one millisecond.</a:t>
             </a:r>
             <a:endParaRPr lang="en-US" dirty="0"/>
           </a:p>
@@ -3257,7 +3340,7 @@
                   <a:schemeClr val="bg2"/>
                 </a:solidFill>
               </a:rPr>
-              <a:t>2019 Intel MacBook Pro · no API key · no GPU · October 2026</a:t>
+              <a:t>Apple M5 Pro · local models · no API key · no admin rights · October 2026</a:t>
             </a:r>
             <a:endParaRPr lang="en-US" sz="1500" dirty="0"/>
           </a:p>
@@ -3415,7 +3498,7 @@
         <p:spPr>
           <a:xfrm>
             <a:off x="457200" y="1188720"/>
-            <a:ext cx="4023360" cy="1773936"/>
+            <a:ext cx="4023360" cy="1746504"/>
           </a:xfrm>
           <a:prstGeom prst="rect">
             <a:avLst/>
@@ -3439,7 +3522,7 @@
         <p:spPr>
           <a:xfrm>
             <a:off x="4663440" y="1188720"/>
-            <a:ext cx="4023360" cy="2267712"/>
+            <a:ext cx="4023360" cy="2395728"/>
           </a:xfrm>
           <a:prstGeom prst="rect">
             <a:avLst/>
@@ -3691,7 +3774,7 @@
                             <a:srgbClr val="FFFFFF"/>
                           </a:solidFill>
                         </a:rPr>
-                        <a:t>Run 2 (qwen2.5vl:3b, ~100 s per drawing)</a:t>
+                        <a:t>qwen2.5vl:3b (5–12 s per drawing)</a:t>
                       </a:r>
                       <a:endParaRPr lang="en-US" sz="1050" dirty="0"/>
                     </a:p>
@@ -3865,7 +3948,7 @@
                             <a:srgbClr val="1F2933"/>
                           </a:solidFill>
                         </a:rPr>
-                        <a:t>36/39, none invented</a:t>
+                        <a:t>38/39, none invented</a:t>
                       </a:r>
                       <a:endParaRPr lang="en-US" sz="1050" dirty="0"/>
                     </a:p>
@@ -4101,7 +4184,7 @@
                             <a:srgbClr val="1F2933"/>
                           </a:solidFill>
                         </a:rPr>
-                        <a:t>5/12</a:t>
+                        <a:t>4/12</a:t>
                       </a:r>
                       <a:endParaRPr lang="en-US" sz="1050" dirty="0"/>
                     </a:p>
@@ -4455,7 +4538,7 @@
                             <a:srgbClr val="1F2933"/>
                           </a:solidFill>
                         </a:rPr>
-                        <a:t>1/3</a:t>
+                        <a:t>0/3</a:t>
                       </a:r>
                       <a:endParaRPr lang="en-US" sz="1050" dirty="0"/>
                     </a:p>
@@ -4652,7 +4735,7 @@
                   <a:schemeClr val="tx1"/>
                 </a:solidFill>
               </a:rPr>
-              <a:t>Synthetic drawings from one template with every tag in a ground-truth file (real P&amp;IDs are confidential). What fails is the same 3B grader that limits the text pipeline, plus the title-block subtitle and small text near symbol edges: exactly what a real set will exercise first. Start a real project from a golden set like this one, on a GPU-class vision model.</a:t>
+              <a:t>Synthetic drawings from one template with every tag in a ground-truth file (real P&amp;IDs are confidential). The right drawing is always retrieved and a 7b vision model reads all 39 tags, but questions about connections (which valve is on the suction side) fail even with bigger models: the next step is storing connections as table rows.</a:t>
             </a:r>
             <a:endParaRPr lang="en-US" sz="1050" dirty="0"/>
           </a:p>
@@ -4913,7 +4996,7 @@
                   <a:schemeClr val="tx1"/>
                 </a:solidFill>
               </a:rPr>
-              <a:t>Test it live (45 min, Docker + Ollama + Python 3.12):</a:t>
+              <a:t>Test it live (Ollama + Python 3.12; a few minutes):</a:t>
             </a:r>
             <a:endParaRPr lang="en-US" sz="1100" dirty="0"/>
           </a:p>
@@ -4987,7 +5070,7 @@
                   <a:schemeClr val="tx1"/>
                 </a:solidFill>
               </a:rPr>
-              <a:t>VERSION_AWARE=0 … "At what disk utilisation should a broker page?" → often 85% (the trap)</a:t>
+              <a:t>python scenarios.py → 12 pass, 5 known weaknesses, 0 unexpected</a:t>
             </a:r>
             <a:endParaRPr lang="en-US" sz="1100" dirty="0"/>
           </a:p>
@@ -5004,7 +5087,7 @@
                   <a:schemeClr val="tx1"/>
                 </a:solidFill>
               </a:rPr>
-              <a:t>VERSION_AWARE=1 … the same question → 75% (the fix)</a:t>
+              <a:t>python b1_eval.py → old versions retrieved 51.6% OFF, 0% ON</a:t>
             </a:r>
             <a:endParaRPr lang="en-US" sz="1100" dirty="0"/>
           </a:p>
@@ -5134,6 +5217,35 @@
                 </a:hlinkClick>
               </a:rPr>
               <a:t>Recreate guide</a:t>
+            </a:r>
+            <a:pPr indent="0" marL="0">
+              <a:buNone/>
+            </a:pPr>
+            <a:r>
+              <a:rPr lang="en-US" sz="1100" dirty="0">
+                <a:solidFill>
+                  <a:schemeClr val="tx1"/>
+                </a:solidFill>
+              </a:rPr>
+              <a:t>  ·  </a:t>
+            </a:r>
+            <a:pPr indent="0" marL="0">
+              <a:buNone/>
+            </a:pPr>
+            <a:r>
+              <a:rPr lang="en-US" sz="1100" u="sng" dirty="0">
+                <a:solidFill>
+                  <a:schemeClr val="accent1"/>
+                </a:solidFill>
+                <a:hlinkClick r:id="rId6" invalidUrl="" action="" tgtFrame="" tooltip="" history="1" highlightClick="0" endSnd="0">
+                  <a:extLst>
+                    <a:ext uri="{A12FA001-AC4F-418D-AE19-62706E023703}">
+                      <ahyp:hlinkClr xmlns:ahyp="http://schemas.microsoft.com/office/drawing/2018/hyperlinkcolor" val="tx"/>
+                    </a:ext>
+                  </a:extLst>
+                </a:hlinkClick>
+              </a:rPr>
+              <a:t>Install guide</a:t>
             </a:r>
             <a:endParaRPr lang="en-US" sz="1100" dirty="0"/>
           </a:p>
@@ -6241,7 +6353,7 @@
                 <a:ea typeface="Courier New" pitchFamily="34" charset="-122"/>
                 <a:cs typeface="Courier New" pitchFamily="34" charset="-120"/>
               </a:rPr>
-              <a:t>open -a Docker; ollama pull llama3.2:3b; ollama pull nomic-embed-text</a:t>
+              <a:t>ollama pull llama3.2:3b; ollama pull nomic-embed-text   # no Docker needed</a:t>
             </a:r>
             <a:endParaRPr lang="en-US" sz="1100" dirty="0"/>
           </a:p>
@@ -6292,7 +6404,7 @@
                 <a:ea typeface="Courier New" pitchFamily="34" charset="-122"/>
                 <a:cs typeface="Courier New" pitchFamily="34" charset="-120"/>
               </a:rPr>
-              <a:t>./run_series.sh mylabel llama3.2:3b     # repeated runs; summarize_series.py mylabel</a:t>
+              <a:t>./services.sh start &amp;&amp; ./services.sh check   # after a reboot: CLEAN START OK</a:t>
             </a:r>
             <a:endParaRPr lang="en-US" sz="1100" dirty="0"/>
           </a:p>
@@ -6656,7 +6768,7 @@
                             <a:srgbClr val="1F2933"/>
                           </a:solidFill>
                         </a:rPr>
-                        <a:t>PASS; pair similarity 0.962–0.990; three negative tests reported</a:t>
+                        <a:t>PASS; pair similarity 0.963–0.990; three negative tests reported</a:t>
                       </a:r>
                       <a:endParaRPr lang="en-US" sz="1050" dirty="0"/>
                     </a:p>
@@ -7095,7 +7207,7 @@
                   <a:schemeClr val="bg2"/>
                 </a:solidFill>
               </a:rPr>
-              <a:t>Next, on a GPU or hosted model: the escalate grader, a real P&amp;ID set with its own golden questions, and LangSmith with a real key.</a:t>
+              <a:t>On an Apple M5 Pro: lean models (~2.7 GB) answer 92.6% / 80%; a second-opinion grader lifts unseen questions to 96%. Next: P&amp;ID connections as data, multi-hop, then deployment.</a:t>
             </a:r>
             <a:endParaRPr lang="en-US" sz="1500" dirty="0"/>
           </a:p>
@@ -7636,7 +7748,7 @@
                   <a:schemeClr val="tx1"/>
                 </a:solidFill>
               </a:rPr>
-              <a:t>Honest negatives: 8B grader on CPU, Docling on Intel macOS</a:t>
+              <a:t>Model choice measured: a second-opinion grader lifts unseen answers 80% → 96%</a:t>
             </a:r>
             <a:endParaRPr lang="en-US" sz="1200" dirty="0"/>
           </a:p>
@@ -7672,7 +7784,7 @@
                   <a:schemeClr val="tx1"/>
                 </a:solidFill>
               </a:rPr>
-              <a:t>Three documents: SOP, runbook, recreate guide; a one-command rebuild</a:t>
+              <a:t>Four documents (SOP, runbook, recreate, install); rebuild and clean-start checks</a:t>
             </a:r>
             <a:endParaRPr lang="en-US" sz="1200" dirty="0"/>
           </a:p>
@@ -8748,8 +8860,8 @@
         </p:nvSpPr>
         <p:spPr>
           <a:xfrm>
-            <a:off x="3291840" y="3218688"/>
-            <a:ext cx="2743200" cy="274320"/>
+            <a:off x="3291840" y="2377440"/>
+            <a:ext cx="4023360" cy="274320"/>
           </a:xfrm>
           <a:prstGeom prst="rect">
             <a:avLst/>
@@ -8958,7 +9070,7 @@
       </p:sp>
       <p:sp>
         <p:nvSpPr>
-          <p:cNvPr id="3" name="card Postgres 16 + pgvector 0.8"/>
+          <p:cNvPr id="3" name="card Postgres 16 + pgvector"/>
           <p:cNvSpPr/>
           <p:nvPr/>
         </p:nvSpPr>
@@ -9013,7 +9125,7 @@
                   <a:schemeClr val="accent1"/>
                 </a:solidFill>
               </a:rPr>
-              <a:t>Postgres 16 + pgvector 0.8</a:t>
+              <a:t>Postgres 16 + pgvector</a:t>
             </a:r>
             <a:endParaRPr lang="en-US" sz="1500" dirty="0"/>
           </a:p>
@@ -9049,7 +9161,7 @@
                   <a:schemeClr val="tx1"/>
                 </a:solidFill>
               </a:rPr>
-              <a:t>In Docker on 127.0.0.1:5433. Tables documents (name, version, superseded, effective_date), chunks (vector(768), HNSW), uploaded_tables.</a:t>
+              <a:t>Native via pgctl.sh, 127.0.0.1:5433. Tables documents (name, version, superseded, effective_date), chunks (vector(768), HNSW), uploaded_tables.</a:t>
             </a:r>
             <a:endParaRPr lang="en-US" sz="1200" dirty="0"/>
           </a:p>
@@ -9148,7 +9260,7 @@
                   <a:schemeClr val="tx1"/>
                 </a:solidFill>
               </a:rPr>
-              <a:t>llama3.2:3b for every LLM call; nomic-embed-text (768 d) for embeddings; qwen2.5vl:3b for drawings. OpenAI-compatible endpoint, so the openai SDK is the only client.</a:t>
+              <a:t>llama3.2:3b for all LLM calls; qwen3:8b as optional grader; nomic-embed-text for embeddings; qwen2.5vl:3b for drawings.</a:t>
             </a:r>
             <a:endParaRPr lang="en-US" sz="1200" dirty="0"/>
           </a:p>
@@ -9453,7 +9565,7 @@
       </p:sp>
       <p:sp>
         <p:nvSpPr>
-          <p:cNvPr id="18" name="card Evaluation scripts"/>
+          <p:cNvPr id="18" name="card Evaluation and operations"/>
           <p:cNvSpPr/>
           <p:nvPr/>
         </p:nvSpPr>
@@ -9508,7 +9620,7 @@
                   <a:schemeClr val="accent1"/>
                 </a:solidFill>
               </a:rPr>
-              <a:t>Evaluation scripts</a:t>
+              <a:t>Evaluation and operations</a:t>
             </a:r>
             <a:endParaRPr lang="en-US" sz="1500" dirty="0"/>
           </a:p>
@@ -9544,7 +9656,7 @@
                   <a:schemeClr val="tx1"/>
                 </a:solidFill>
               </a:rPr>
-              <a:t>eval.py (answer level), b1_eval.py (retrieval OFF/ON), b1_check.py (data checks + negative tests), pid_eval.py, summarize_series.py, recreate.sh.</a:t>
+              <a:t>eval.py, b1_eval.py (filter OFF/ON), b1_check.py, scenarios.py, pid_eval.py, recreate.sh, services.sh check.</a:t>
             </a:r>
             <a:endParaRPr lang="en-US" sz="1200" dirty="0"/>
           </a:p>
@@ -9652,7 +9764,7 @@
                   <a:schemeClr val="tx2"/>
                 </a:solidFill>
               </a:rPr>
-              <a:t>Twenty-five steps in six phases</a:t>
+              <a:t>From pre-work to troubleshooting</a:t>
             </a:r>
             <a:endParaRPr lang="en-US" sz="2800" dirty="0"/>
           </a:p>
@@ -9773,7 +9885,7 @@
                   <a:schemeClr val="tx2"/>
                 </a:solidFill>
               </a:rPr>
-              <a:t>Build</a:t>
+              <a:t>Pre-work</a:t>
             </a:r>
             <a:endParaRPr lang="en-US" sz="1500" dirty="0"/>
           </a:p>
@@ -9809,7 +9921,7 @@
                   <a:schemeClr val="tx1"/>
                 </a:solidFill>
               </a:rPr>
-              <a:t>DB, ingest, graph, golden set frozen before any code, eval, API + UI (steps 1–8)</a:t>
+              <a:t>requirements, design decisions, rules that keep results honest (SOP 3)</a:t>
             </a:r>
             <a:endParaRPr lang="en-US" sz="1050" dirty="0"/>
           </a:p>
@@ -9930,7 +10042,7 @@
                   <a:schemeClr val="tx2"/>
                 </a:solidFill>
               </a:rPr>
-              <a:t>Improve</a:t>
+              <a:t>Prepare</a:t>
             </a:r>
             <a:endParaRPr lang="en-US" sz="1500" dirty="0"/>
           </a:p>
@@ -9966,7 +10078,7 @@
                   <a:schemeClr val="tx1"/>
                 </a:solidFill>
               </a:rPr>
-              <a:t>router, SQL rules, per-passage grader; one change at a time, committed before measuring (9–14)</a:t>
+              <a:t>uv, Python 3.12, Ollama, two required models; no admin rights (SOP 4)</a:t>
             </a:r>
             <a:endParaRPr lang="en-US" sz="1050" dirty="0"/>
           </a:p>
@@ -10087,7 +10199,7 @@
                   <a:schemeClr val="tx2"/>
                 </a:solidFill>
               </a:rPr>
-              <a:t>Measure</a:t>
+              <a:t>Implement</a:t>
             </a:r>
             <a:endParaRPr lang="en-US" sz="1500" dirty="0"/>
           </a:p>
@@ -10123,7 +10235,7 @@
                   <a:schemeClr val="tx1"/>
                 </a:solidFill>
               </a:rPr>
-              <a:t>25 unseen questions, 3+4 repeated runs, mean and range, the gap stated (15–18)</a:t>
+              <a:t>native Postgres, schema, ingestion, graph, interfaces, P&amp;ID, Docling (SOP 5)</a:t>
             </a:r>
             <a:endParaRPr lang="en-US" sz="1050" dirty="0"/>
           </a:p>
@@ -10138,163 +10250,6 @@
         <p:spPr>
           <a:xfrm>
             <a:off x="5120640" y="1188720"/>
-            <a:ext cx="548640" cy="548640"/>
-          </a:xfrm>
-          <a:prstGeom prst="ellipse">
-            <a:avLst/>
-          </a:prstGeom>
-          <a:solidFill>
-            <a:srgbClr val="B54141"/>
-          </a:solidFill>
-          <a:ln w="12700">
-            <a:solidFill>
-              <a:srgbClr val="FFFFFF"/>
-            </a:solidFill>
-            <a:prstDash val="solid"/>
-          </a:ln>
-        </p:spPr>
-      </p:sp>
-      <p:sp>
-        <p:nvSpPr>
-          <p:cNvPr id="19" name="Text 17"/>
-          <p:cNvSpPr txBox="1"/>
-          <p:nvPr/>
-        </p:nvSpPr>
-        <p:spPr>
-          <a:xfrm>
-            <a:off x="5120640" y="1188720"/>
-            <a:ext cx="548640" cy="548640"/>
-          </a:xfrm>
-          <a:prstGeom prst="rect">
-            <a:avLst/>
-          </a:prstGeom>
-          <a:noFill/>
-          <a:ln/>
-        </p:spPr>
-        <p:txBody>
-          <a:bodyPr wrap="square" lIns="0" tIns="0" rIns="0" bIns="0" rtlCol="0" anchor="ctr"/>
-          <a:lstStyle/>
-          <a:p>
-            <a:pPr algn="ctr" indent="0" marL="0">
-              <a:buNone/>
-            </a:pPr>
-            <a:r>
-              <a:rPr lang="en-US" sz="1800" b="1" dirty="0">
-                <a:solidFill>
-                  <a:schemeClr val="bg1"/>
-                </a:solidFill>
-              </a:rPr>
-              <a:t>4</a:t>
-            </a:r>
-            <a:endParaRPr lang="en-US" sz="1800" dirty="0"/>
-          </a:p>
-        </p:txBody>
-      </p:sp>
-      <p:sp>
-        <p:nvSpPr>
-          <p:cNvPr id="20" name="arrow"/>
-          <p:cNvSpPr/>
-          <p:nvPr/>
-        </p:nvSpPr>
-        <p:spPr>
-          <a:xfrm>
-            <a:off x="5715000" y="1463040"/>
-            <a:ext cx="777240" cy="9144"/>
-          </a:xfrm>
-          <a:prstGeom prst="line">
-            <a:avLst/>
-          </a:prstGeom>
-          <a:noFill/>
-          <a:ln w="19050">
-            <a:solidFill>
-              <a:srgbClr val="5F6B76"/>
-            </a:solidFill>
-            <a:prstDash val="solid"/>
-            <a:tailEnd type="triangle"/>
-          </a:ln>
-        </p:spPr>
-      </p:sp>
-      <p:sp>
-        <p:nvSpPr>
-          <p:cNvPr id="21" name="Text 19"/>
-          <p:cNvSpPr txBox="1"/>
-          <p:nvPr/>
-        </p:nvSpPr>
-        <p:spPr>
-          <a:xfrm>
-            <a:off x="4709160" y="1874520"/>
-            <a:ext cx="1371600" cy="365760"/>
-          </a:xfrm>
-          <a:prstGeom prst="rect">
-            <a:avLst/>
-          </a:prstGeom>
-          <a:noFill/>
-          <a:ln/>
-        </p:spPr>
-        <p:txBody>
-          <a:bodyPr wrap="square" lIns="0" tIns="0" rIns="0" bIns="0" rtlCol="0" anchor="ctr"/>
-          <a:lstStyle/>
-          <a:p>
-            <a:pPr algn="ctr" indent="0" marL="0">
-              <a:buNone/>
-            </a:pPr>
-            <a:r>
-              <a:rPr lang="en-US" sz="1500" b="1" dirty="0">
-                <a:solidFill>
-                  <a:schemeClr val="tx2"/>
-                </a:solidFill>
-              </a:rPr>
-              <a:t>Negative</a:t>
-            </a:r>
-            <a:endParaRPr lang="en-US" sz="1500" dirty="0"/>
-          </a:p>
-        </p:txBody>
-      </p:sp>
-      <p:sp>
-        <p:nvSpPr>
-          <p:cNvPr id="22" name="Text 20"/>
-          <p:cNvSpPr txBox="1"/>
-          <p:nvPr/>
-        </p:nvSpPr>
-        <p:spPr>
-          <a:xfrm>
-            <a:off x="4709160" y="2286000"/>
-            <a:ext cx="1371600" cy="1828800"/>
-          </a:xfrm>
-          <a:prstGeom prst="rect">
-            <a:avLst/>
-          </a:prstGeom>
-          <a:noFill/>
-          <a:ln/>
-        </p:spPr>
-        <p:txBody>
-          <a:bodyPr wrap="square" lIns="0" tIns="0" rIns="0" bIns="0" rtlCol="0" anchor="t"/>
-          <a:lstStyle/>
-          <a:p>
-            <a:pPr algn="ctr" indent="0" marL="0">
-              <a:buNone/>
-            </a:pPr>
-            <a:r>
-              <a:rPr lang="en-US" sz="1050" dirty="0">
-                <a:solidFill>
-                  <a:schemeClr val="tx1"/>
-                </a:solidFill>
-              </a:rPr>
-              <a:t>8B grader on this CPU: recorded with evidence, switch kept for a GPU (19)</a:t>
-            </a:r>
-            <a:endParaRPr lang="en-US" sz="1050" dirty="0"/>
-          </a:p>
-        </p:txBody>
-      </p:sp>
-      <p:sp>
-        <p:nvSpPr>
-          <p:cNvPr id="23" name="phase 5"/>
-          <p:cNvSpPr/>
-          <p:nvPr/>
-        </p:nvSpPr>
-        <p:spPr>
-          <a:xfrm>
-            <a:off x="6537960" y="1188720"/>
             <a:ext cx="548640" cy="548640"/>
           </a:xfrm>
           <a:prstGeom prst="ellipse">
@@ -10313,13 +10268,13 @@
       </p:sp>
       <p:sp>
         <p:nvSpPr>
-          <p:cNvPr id="24" name="Text 22"/>
+          <p:cNvPr id="19" name="Text 17"/>
           <p:cNvSpPr txBox="1"/>
           <p:nvPr/>
         </p:nvSpPr>
         <p:spPr>
           <a:xfrm>
-            <a:off x="6537960" y="1188720"/>
+            <a:off x="5120640" y="1188720"/>
             <a:ext cx="548640" cy="548640"/>
           </a:xfrm>
           <a:prstGeom prst="rect">
@@ -10341,7 +10296,7 @@
                   <a:schemeClr val="bg1"/>
                 </a:solidFill>
               </a:rPr>
-              <a:t>5</a:t>
+              <a:t>4</a:t>
             </a:r>
             <a:endParaRPr lang="en-US" sz="1800" dirty="0"/>
           </a:p>
@@ -10349,13 +10304,13 @@
       </p:sp>
       <p:sp>
         <p:nvSpPr>
-          <p:cNvPr id="25" name="arrow"/>
+          <p:cNvPr id="20" name="arrow"/>
           <p:cNvSpPr/>
           <p:nvPr/>
         </p:nvSpPr>
         <p:spPr>
           <a:xfrm>
-            <a:off x="7132320" y="1463040"/>
+            <a:off x="5715000" y="1463040"/>
             <a:ext cx="777240" cy="9144"/>
           </a:xfrm>
           <a:prstGeom prst="line">
@@ -10373,13 +10328,13 @@
       </p:sp>
       <p:sp>
         <p:nvSpPr>
-          <p:cNvPr id="26" name="Text 24"/>
+          <p:cNvPr id="21" name="Text 19"/>
           <p:cNvSpPr txBox="1"/>
           <p:nvPr/>
         </p:nvSpPr>
         <p:spPr>
           <a:xfrm>
-            <a:off x="6126480" y="1874520"/>
+            <a:off x="4709160" y="1874520"/>
             <a:ext cx="1371600" cy="365760"/>
           </a:xfrm>
           <a:prstGeom prst="rect">
@@ -10401,7 +10356,7 @@
                   <a:schemeClr val="tx2"/>
                 </a:solidFill>
               </a:rPr>
-              <a:t>Versions</a:t>
+              <a:t>Test</a:t>
             </a:r>
             <a:endParaRPr lang="en-US" sz="1500" dirty="0"/>
           </a:p>
@@ -10409,13 +10364,13 @@
       </p:sp>
       <p:sp>
         <p:nvSpPr>
-          <p:cNvPr id="27" name="Text 25"/>
+          <p:cNvPr id="22" name="Text 20"/>
           <p:cNvSpPr txBox="1"/>
           <p:nvPr/>
         </p:nvSpPr>
         <p:spPr>
           <a:xfrm>
-            <a:off x="6126480" y="2286000"/>
+            <a:off x="4709160" y="2286000"/>
             <a:ext cx="1371600" cy="1828800"/>
           </a:xfrm>
           <a:prstGeom prst="rect">
@@ -10437,7 +10392,7 @@
                   <a:schemeClr val="tx1"/>
                 </a:solidFill>
               </a:rPr>
-              <a:t>16 runbooks old/current, data checks, OFF/ON ablation, default ON (20)</a:t>
+              <a:t>clean start, fingerprints, filter OFF/ON, 18 scenarios, 3 runs per set (SOP 6)</a:t>
             </a:r>
             <a:endParaRPr lang="en-US" sz="1050" dirty="0"/>
           </a:p>
@@ -10445,13 +10400,13 @@
       </p:sp>
       <p:sp>
         <p:nvSpPr>
-          <p:cNvPr id="28" name="phase 6"/>
+          <p:cNvPr id="23" name="phase 5"/>
           <p:cNvSpPr/>
           <p:nvPr/>
         </p:nvSpPr>
         <p:spPr>
           <a:xfrm>
-            <a:off x="7955280" y="1188720"/>
+            <a:off x="6537960" y="1188720"/>
             <a:ext cx="548640" cy="548640"/>
           </a:xfrm>
           <a:prstGeom prst="ellipse">
@@ -10470,6 +10425,163 @@
       </p:sp>
       <p:sp>
         <p:nvSpPr>
+          <p:cNvPr id="24" name="Text 22"/>
+          <p:cNvSpPr txBox="1"/>
+          <p:nvPr/>
+        </p:nvSpPr>
+        <p:spPr>
+          <a:xfrm>
+            <a:off x="6537960" y="1188720"/>
+            <a:ext cx="548640" cy="548640"/>
+          </a:xfrm>
+          <a:prstGeom prst="rect">
+            <a:avLst/>
+          </a:prstGeom>
+          <a:noFill/>
+          <a:ln/>
+        </p:spPr>
+        <p:txBody>
+          <a:bodyPr wrap="square" lIns="0" tIns="0" rIns="0" bIns="0" rtlCol="0" anchor="ctr"/>
+          <a:lstStyle/>
+          <a:p>
+            <a:pPr algn="ctr" indent="0" marL="0">
+              <a:buNone/>
+            </a:pPr>
+            <a:r>
+              <a:rPr lang="en-US" sz="1800" b="1" dirty="0">
+                <a:solidFill>
+                  <a:schemeClr val="bg1"/>
+                </a:solidFill>
+              </a:rPr>
+              <a:t>5</a:t>
+            </a:r>
+            <a:endParaRPr lang="en-US" sz="1800" dirty="0"/>
+          </a:p>
+        </p:txBody>
+      </p:sp>
+      <p:sp>
+        <p:nvSpPr>
+          <p:cNvPr id="25" name="arrow"/>
+          <p:cNvSpPr/>
+          <p:nvPr/>
+        </p:nvSpPr>
+        <p:spPr>
+          <a:xfrm>
+            <a:off x="7132320" y="1463040"/>
+            <a:ext cx="777240" cy="9144"/>
+          </a:xfrm>
+          <a:prstGeom prst="line">
+            <a:avLst/>
+          </a:prstGeom>
+          <a:noFill/>
+          <a:ln w="19050">
+            <a:solidFill>
+              <a:srgbClr val="5F6B76"/>
+            </a:solidFill>
+            <a:prstDash val="solid"/>
+            <a:tailEnd type="triangle"/>
+          </a:ln>
+        </p:spPr>
+      </p:sp>
+      <p:sp>
+        <p:nvSpPr>
+          <p:cNvPr id="26" name="Text 24"/>
+          <p:cNvSpPr txBox="1"/>
+          <p:nvPr/>
+        </p:nvSpPr>
+        <p:spPr>
+          <a:xfrm>
+            <a:off x="6126480" y="1874520"/>
+            <a:ext cx="1371600" cy="365760"/>
+          </a:xfrm>
+          <a:prstGeom prst="rect">
+            <a:avLst/>
+          </a:prstGeom>
+          <a:noFill/>
+          <a:ln/>
+        </p:spPr>
+        <p:txBody>
+          <a:bodyPr wrap="square" lIns="0" tIns="0" rIns="0" bIns="0" rtlCol="0" anchor="ctr"/>
+          <a:lstStyle/>
+          <a:p>
+            <a:pPr algn="ctr" indent="0" marL="0">
+              <a:buNone/>
+            </a:pPr>
+            <a:r>
+              <a:rPr lang="en-US" sz="1500" b="1" dirty="0">
+                <a:solidFill>
+                  <a:schemeClr val="tx2"/>
+                </a:solidFill>
+              </a:rPr>
+              <a:t>Operate</a:t>
+            </a:r>
+            <a:endParaRPr lang="en-US" sz="1500" dirty="0"/>
+          </a:p>
+        </p:txBody>
+      </p:sp>
+      <p:sp>
+        <p:nvSpPr>
+          <p:cNvPr id="27" name="Text 25"/>
+          <p:cNvSpPr txBox="1"/>
+          <p:nvPr/>
+        </p:nvSpPr>
+        <p:spPr>
+          <a:xfrm>
+            <a:off x="6126480" y="2286000"/>
+            <a:ext cx="1371600" cy="1828800"/>
+          </a:xfrm>
+          <a:prstGeom prst="rect">
+            <a:avLst/>
+          </a:prstGeom>
+          <a:noFill/>
+          <a:ln/>
+        </p:spPr>
+        <p:txBody>
+          <a:bodyPr wrap="square" lIns="0" tIns="0" rIns="0" bIns="0" rtlCol="0" anchor="t"/>
+          <a:lstStyle/>
+          <a:p>
+            <a:pPr algn="ctr" indent="0" marL="0">
+              <a:buNone/>
+            </a:pPr>
+            <a:r>
+              <a:rPr lang="en-US" sz="1050" dirty="0">
+                <a:solidFill>
+                  <a:schemeClr val="tx1"/>
+                </a:solidFill>
+              </a:rPr>
+              <a:t>services.sh, backups, model profiles, change control (runbook)</a:t>
+            </a:r>
+            <a:endParaRPr lang="en-US" sz="1050" dirty="0"/>
+          </a:p>
+        </p:txBody>
+      </p:sp>
+      <p:sp>
+        <p:nvSpPr>
+          <p:cNvPr id="28" name="phase 6"/>
+          <p:cNvSpPr/>
+          <p:nvPr/>
+        </p:nvSpPr>
+        <p:spPr>
+          <a:xfrm>
+            <a:off x="7955280" y="1188720"/>
+            <a:ext cx="548640" cy="548640"/>
+          </a:xfrm>
+          <a:prstGeom prst="ellipse">
+            <a:avLst/>
+          </a:prstGeom>
+          <a:solidFill>
+            <a:srgbClr val="0F766E"/>
+          </a:solidFill>
+          <a:ln w="12700">
+            <a:solidFill>
+              <a:srgbClr val="FFFFFF"/>
+            </a:solidFill>
+            <a:prstDash val="solid"/>
+          </a:ln>
+        </p:spPr>
+      </p:sp>
+      <p:sp>
+        <p:nvSpPr>
           <p:cNvPr id="29" name="Text 27"/>
           <p:cNvSpPr txBox="1"/>
           <p:nvPr/>
@@ -10534,7 +10646,7 @@
                   <a:schemeClr val="tx2"/>
                 </a:solidFill>
               </a:rPr>
-              <a:t>Close out</a:t>
+              <a:t>Troubleshoot</a:t>
             </a:r>
             <a:endParaRPr lang="en-US" sz="1500" dirty="0"/>
           </a:p>
@@ -10570,7 +10682,7 @@
                   <a:schemeClr val="tx1"/>
                 </a:solidFill>
               </a:rPr>
-              <a:t>browser checks, LangSmith opt-in, static front end, P&amp;ID branch, site (21–25)</a:t>
+              <a:t>symptom, cause and fix for every problem met (SOP 8, runbook 5)</a:t>
             </a:r>
             <a:endParaRPr lang="en-US" sz="1050" dirty="0"/>
           </a:p>
@@ -10606,7 +10718,7 @@
                   <a:schemeClr val="accent5"/>
                 </a:solidFill>
               </a:rPr>
-              <a:t>Every step in the SOP has the problem found, the change, how it was verified, and the commands used.</a:t>
+              <a:t>Every step in the SOP has its commands, the expected output and the result measured on the M5 Pro.</a:t>
             </a:r>
             <a:endParaRPr lang="en-US" sz="1200" dirty="0"/>
           </a:p>
@@ -10714,7 +10826,7 @@
                   <a:schemeClr val="tx2"/>
                 </a:solidFill>
               </a:rPr>
-              <a:t>How the numbers were kept honest</a:t>
+              <a:t>How the numbers are kept honest</a:t>
             </a:r>
             <a:endParaRPr lang="en-US" sz="2800" dirty="0"/>
           </a:p>
@@ -11210,7 +11322,7 @@
                   <a:schemeClr val="tx2"/>
                 </a:solidFill>
               </a:rPr>
-              <a:t>Report ranges</a:t>
+              <a:t>Repeat and compare</a:t>
             </a:r>
             <a:endParaRPr lang="en-US" sz="1400" dirty="0"/>
           </a:p>
@@ -11246,7 +11358,7 @@
                   <a:schemeClr val="tx1"/>
                 </a:solidFill>
               </a:rPr>
-              <a:t>Three held-out runs and four tuned-set runs; the 7.6-point gap between them is stated as the over-fitting measure.</a:t>
+              <a:t>Three runs on each set (identical on this machine); the tuned (92.6%) and unseen (80%) sets are reported side by side.</a:t>
             </a:r>
             <a:endParaRPr lang="en-US" sz="1100" dirty="0"/>
           </a:p>
@@ -11379,7 +11491,7 @@
                   <a:schemeClr val="tx1"/>
                 </a:solidFill>
               </a:rPr>
-              <a:t>OFF and ON interleaved in one process after a warm-up; a single cold run once showed a false 3× difference.</a:t>
+              <a:t>OFF and ON interleaved in one run after a warm-up; quoted as a range (12–13 ms) because runs differ by a millisecond.</a:t>
             </a:r>
             <a:endParaRPr lang="en-US" sz="1100" dirty="0"/>
           </a:p>
@@ -11476,7 +11588,7 @@
                   <a:schemeClr val="tx2"/>
                 </a:solidFill>
               </a:rPr>
-              <a:t>Record negatives</a:t>
+              <a:t>Score as frozen</a:t>
             </a:r>
             <a:endParaRPr lang="en-US" sz="1400" dirty="0"/>
           </a:p>
@@ -11512,7 +11624,7 @@
                   <a:schemeClr val="tx1"/>
                 </a:solidFill>
               </a:rPr>
-              <a:t>qwen3:8b could not grade six passages in usable time on this CPU; the switch stays, the evidence is in the SOP.</a:t>
+              <a:t>llama3.1:8b refused one question in other words; it stays scored as a failure instead of changing the scorer.</a:t>
             </a:r>
             <a:endParaRPr lang="en-US" sz="1100" dirty="0"/>
           </a:p>
@@ -11672,7 +11784,7 @@
                   <a:schemeClr val="accent4"/>
                 </a:solidFill>
               </a:rPr>
-              <a:t>7.6 pts</a:t>
+              <a:t>80 → 96%</a:t>
             </a:r>
             <a:endParaRPr lang="en-US" sz="3600" dirty="0"/>
           </a:p>
@@ -11708,7 +11820,7 @@
                   <a:schemeClr val="accent5"/>
                 </a:solidFill>
               </a:rPr>
-              <a:t>the gap between tuned and unseen answer accuracy: the honest measure of over-fitting</a:t>
+              <a:t>unseen answers with a qwen3:8b second-opinion grader that loads only for hard questions</a:t>
             </a:r>
             <a:endParaRPr lang="en-US" sz="1100" dirty="0"/>
           </a:p>
@@ -11744,7 +11856,7 @@
                   <a:schemeClr val="accent2"/>
                 </a:solidFill>
               </a:rPr>
-              <a:t>4 cases</a:t>
+              <a:t>5 cases</a:t>
             </a:r>
             <a:endParaRPr lang="en-US" sz="3600" dirty="0"/>
           </a:p>
@@ -11780,7 +11892,7 @@
                   <a:schemeClr val="accent5"/>
                 </a:solidFill>
               </a:rPr>
-              <a:t>fail in every held-out run: three are the 3B grader rejecting a differently phrased passage, one is a router ambiguity</a:t>
+              <a:t>documented weaknesses in the scenario catalogue: grader, multi-hop, SQL, two P&amp;ID relations</a:t>
             </a:r>
             <a:endParaRPr lang="en-US" sz="1100" dirty="0"/>
           </a:p>
@@ -12619,7 +12731,7 @@
                             <a:srgbClr val="1F2933"/>
                           </a:solidFill>
                         </a:rPr>
-                        <a:t>56 ms</a:t>
+                        <a:t>12–13 ms</a:t>
                       </a:r>
                       <a:endParaRPr lang="en-US" sz="1050" dirty="0"/>
                     </a:p>
@@ -12677,7 +12789,7 @@
                             <a:srgbClr val="1F2933"/>
                           </a:solidFill>
                         </a:rPr>
-                        <a:t>57 ms</a:t>
+                        <a:t>12–13 ms</a:t>
                       </a:r>
                       <a:endParaRPr lang="en-US" sz="1050" dirty="0"/>
                     </a:p>
@@ -12795,7 +12907,7 @@
                             <a:srgbClr val="1F2933"/>
                           </a:solidFill>
                         </a:rPr>
-                        <a:t>0.962 – 0.990</a:t>
+                        <a:t>0.963 – 0.990</a:t>
                       </a:r>
                       <a:endParaRPr lang="en-US" sz="1050" dirty="0"/>
                     </a:p>
@@ -12913,7 +13025,7 @@
                   <a:schemeClr val="accent5"/>
                 </a:solidFill>
               </a:rPr>
-              <a:t>At answer level both settings scored 88.9% on this corpus (its current runbooks name their former values); multi-hop improved 0/2 → 1/2 with the filter on.</a:t>
+              <a:t>At answer level the filter raised the 27-question score from 88.9% to 92.6% (multi-hop 0/2 → 1/2); version questions were 8/8 both ways because each current runbook names its former value.</a:t>
             </a:r>
             <a:endParaRPr lang="en-US" sz="1050" dirty="0"/>
           </a:p>
@@ -13029,7 +13141,7 @@
       </p:sp>
       <p:sp>
         <p:nvSpPr>
-          <p:cNvPr id="3" name="card Stronger grader: tested, not possible here"/>
+          <p:cNvPr id="3" name="card Second-opinion grader: recommended"/>
           <p:cNvSpPr/>
           <p:nvPr/>
         </p:nvSpPr>
@@ -13081,10 +13193,10 @@
             <a:r>
               <a:rPr lang="en-US" sz="1500" b="1" dirty="0">
                 <a:solidFill>
-                  <a:schemeClr val="accent2"/>
-                </a:solidFill>
-              </a:rPr>
-              <a:t>Stronger grader: tested, not possible here</a:t>
+                  <a:schemeClr val="accent3"/>
+                </a:solidFill>
+              </a:rPr>
+              <a:t>Second-opinion grader: recommended</a:t>
             </a:r>
             <a:endParaRPr lang="en-US" sz="1500" dirty="0"/>
           </a:p>
@@ -13120,7 +13232,7 @@
                   <a:schemeClr val="tx1"/>
                 </a:solidFill>
               </a:rPr>
-              <a:t>qwen3:8b grades one passage in 33–52 s but never returned six passages in 20 minutes on this CPU; the runner sat at 578% CPU. The escalate design and switch are in place for a GPU or hosted model.</a:t>
+              <a:t>qwen3:8b reads the six passages only when the 3B grader keeps none: unseen answers 80% → 96%, about 3 s for a hard question, unloaded after 5 minutes idle.</a:t>
             </a:r>
             <a:endParaRPr lang="en-US" sz="1200" dirty="0"/>
           </a:p>
@@ -13227,7 +13339,7 @@
       </p:sp>
       <p:sp>
         <p:nvSpPr>
-          <p:cNvPr id="9" name="card Docling: blocked on Intel macOS"/>
+          <p:cNvPr id="9" name="card Bigger models: tested, not kept"/>
           <p:cNvSpPr/>
           <p:nvPr/>
         </p:nvSpPr>
@@ -13282,7 +13394,7 @@
                   <a:schemeClr val="accent4"/>
                 </a:solidFill>
               </a:rPr>
-              <a:t>Docling: blocked on Intel macOS</a:t>
+              <a:t>Bigger models: tested, not kept</a:t>
             </a:r>
             <a:endParaRPr lang="en-US" sz="1500" dirty="0"/>
           </a:p>
@@ -13318,7 +13430,7 @@
                   <a:schemeClr val="tx1"/>
                 </a:solidFill>
               </a:rPr>
-              <a:t>Last torch wheel is 2.2.2; the layout model needs newer transformers and numpy 2. PDFs use pypdf text; run Docling elsewhere and ingest the Markdown.</a:t>
+              <a:t>llama3.1:8b for every step scored 92% unseen and stays 5.2 GB resident; qwen2.5vl:7b gave +2 P&amp;ID answers for +2.7 GB. Both were removed.</a:t>
             </a:r>
             <a:endParaRPr lang="en-US" sz="1200" dirty="0"/>
           </a:p>
@@ -13326,7 +13438,7 @@
       </p:sp>
       <p:sp>
         <p:nvSpPr>
-          <p:cNvPr id="12" name="card The 'outages' were sleep"/>
+          <p:cNvPr id="12" name="card No Docker, no admin rights"/>
           <p:cNvSpPr/>
           <p:nvPr/>
         </p:nvSpPr>
@@ -13381,7 +13493,7 @@
                   <a:schemeClr val="accent3"/>
                 </a:solidFill>
               </a:rPr>
-              <a:t>The 'outages' were sleep</a:t>
+              <a:t>No Docker, no admin rights</a:t>
             </a:r>
             <a:endParaRPr lang="en-US" sz="1500" dirty="0"/>
           </a:p>
@@ -13417,7 +13529,7 @@
                   <a:schemeClr val="tx1"/>
                 </a:solidFill>
               </a:rPr>
-              <a:t>Three service failures traced in the system log to the Mac sleeping; every long script now re-execs under caffeinate, and the runbook has the checklist.</a:t>
+              <a:t>Postgres + pgvector run natively from a pip wheel through pgctl.sh; Ollama is a standalone binary; services.sh check proves a clean start.</a:t>
             </a:r>
             <a:endParaRPr lang="en-US" sz="1200" dirty="0"/>
           </a:p>

</xml_diff>

<commit_message>
Point links, clone commands and publish_site.sh at the ragcap-m5 repository
publish_site.sh now publishes the site to the gh-pages branch of ragcap-m5, so
it never writes to the original ragcap repository. The site is marked as not
published yet.

Co-Authored-By: Claude Opus 5.5 <noreply@anthropic.com>
</commit_message>
<xml_diff>
--- a/docs/ragcap_deck.pptx
+++ b/docs/ragcap_deck.pptx
@@ -121,39 +121,39 @@
   <p:extLst>
     <p:ext uri="{521415D9-36F7-43E2-AB2F-B90AF26B5E84}">
       <p14:sectionLst xmlns:p14="http://schemas.microsoft.com/office/powerpoint/2010/main">
-        <p14:section name="Overview" id="{35e826de-12ee-8f53-2348-7d7b8da9b615}">
+        <p14:section name="Overview" id="{2558f68c-706e-f423-5a25-3dd5af4d4287}">
           <p14:sldIdLst>
             <p14:sldId id="256"/>
             <p14:sldId id="257"/>
           </p14:sldIdLst>
         </p14:section>
-        <p14:section name="How it works" id="{3442120d-3bf7-c164-0305-3aa91107affa}">
+        <p14:section name="How it works" id="{25a1a753-8f31-a572-3bb4-ab0e3a5ee68a}">
           <p14:sldIdLst>
             <p14:sldId id="258"/>
             <p14:sldId id="259"/>
           </p14:sldIdLst>
         </p14:section>
-        <p14:section name="How it is built" id="{85ceec96-cc9d-90d4-b62a-05633feddffe}">
+        <p14:section name="How it is built" id="{c34620f7-57fa-4ca5-531b-0106f82f67ca}">
           <p14:sldIdLst>
             <p14:sldId id="260"/>
             <p14:sldId id="261"/>
           </p14:sldIdLst>
         </p14:section>
-        <p14:section name="Results" id="{540ebe72-ffb6-3d4f-56a8-0ad39975362b}">
+        <p14:section name="Results" id="{81a14aa3-8277-0ec1-a642-46c167a78b47}">
           <p14:sldIdLst>
             <p14:sldId id="262"/>
             <p14:sldId id="263"/>
             <p14:sldId id="264"/>
           </p14:sldIdLst>
         </p14:section>
-        <p14:section name="Showcase" id="{a3c1607e-a440-2837-32ab-93d5b9d58ed2}">
+        <p14:section name="Showcase" id="{12fa59e3-ca20-e096-f83f-8bd2ef48b0ec}">
           <p14:sldIdLst>
             <p14:sldId id="265"/>
             <p14:sldId id="266"/>
             <p14:sldId id="267"/>
           </p14:sldIdLst>
         </p14:section>
-        <p14:section name="Deploy" id="{70f147b0-c54a-692d-404d-0c34970e05fe}">
+        <p14:section name="Deploy" id="{4105f9a4-6c58-e35f-5612-a568df3c5eef}">
           <p14:sldIdLst>
             <p14:sldId id="268"/>
             <p14:sldId id="269"/>
@@ -2856,7 +2856,7 @@
                   <a:schemeClr val="accent5"/>
                 </a:solidFill>
               </a:rPr>
-              <a:t>ragcap  ·  github.com/shreenathacc22/ragcap</a:t>
+              <a:t>ragcap  ·  github.com/shreenathacc22/ragcap-m5</a:t>
             </a:r>
             <a:endParaRPr lang="en-US" sz="900" dirty="0"/>
           </a:p>
@@ -3383,7 +3383,7 @@
                   </a:extLst>
                 </a:hlinkClick>
               </a:rPr>
-              <a:t>https://github.com/shreenathacc22/ragcap</a:t>
+              <a:t>https://github.com/shreenathacc22/ragcap-m5</a:t>
             </a:r>
             <a:pPr indent="0" marL="0">
               <a:buNone/>
@@ -3412,7 +3412,7 @@
                   </a:extLst>
                 </a:hlinkClick>
               </a:rPr>
-              <a:t>https://shreenathacc22.github.io/ragcap/</a:t>
+              <a:t>https://shreenathacc22.github.io/ragcap-m5/</a:t>
             </a:r>
             <a:endParaRPr lang="en-US" sz="1200" dirty="0"/>
           </a:p>
@@ -4903,7 +4903,7 @@
                   <a:schemeClr val="tx1"/>
                 </a:solidFill>
               </a:rPr>
-              <a:t>Live showcase (GitHub Pages, static): </a:t>
+              <a:t>Showcase (GitHub Pages, once published): </a:t>
             </a:r>
             <a:pPr indent="0" marL="0">
               <a:buNone/>
@@ -4921,7 +4921,7 @@
                   </a:extLst>
                 </a:hlinkClick>
               </a:rPr>
-              <a:t>https://shreenathacc22.github.io/ragcap/</a:t>
+              <a:t>https://shreenathacc22.github.io/ragcap-m5/</a:t>
             </a:r>
             <a:endParaRPr lang="en-US" sz="1200" dirty="0"/>
           </a:p>
@@ -5008,7 +5008,7 @@
               <a:buNone/>
             </a:pPr>
             <a:r>
-              <a:rPr lang="en-US" sz="950" dirty="0">
+              <a:rPr lang="en-US" sz="850" dirty="0">
                 <a:solidFill>
                   <a:schemeClr val="tx1"/>
                 </a:solidFill>
@@ -5016,7 +5016,7 @@
                 <a:ea typeface="Courier New" pitchFamily="34" charset="-122"/>
                 <a:cs typeface="Courier New" pitchFamily="34" charset="-120"/>
               </a:rPr>
-              <a:t>git clone https://github.com/shreenathacc22/ragcap</a:t>
+              <a:t>git clone https://github.com/shreenathacc22/ragcap-m5</a:t>
             </a:r>
             <a:endParaRPr lang="en-US" sz="1100" dirty="0"/>
           </a:p>
@@ -5036,7 +5036,7 @@
                 <a:ea typeface="Courier New" pitchFamily="34" charset="-122"/>
                 <a:cs typeface="Courier New" pitchFamily="34" charset="-120"/>
               </a:rPr>
-              <a:t>cd ragcap &amp;&amp; ./recreate.sh</a:t>
+              <a:t>cd ragcap-m5 &amp;&amp; ./recreate.sh</a:t>
             </a:r>
             <a:endParaRPr lang="en-US" sz="1100" dirty="0"/>
           </a:p>
@@ -5486,7 +5486,7 @@
                   <a:schemeClr val="tx1"/>
                 </a:solidFill>
               </a:rPr>
-              <a:t>vercel.com → Continue with GitHub (the account that owns shreenathacc22/ragcap).</a:t>
+              <a:t>vercel.com → Continue with GitHub (the account that owns shreenathacc22/ragcap-m5).</a:t>
             </a:r>
             <a:endParaRPr lang="en-US" sz="1050" dirty="0"/>
           </a:p>
@@ -5619,7 +5619,7 @@
                   <a:schemeClr val="tx1"/>
                 </a:solidFill>
               </a:rPr>
-              <a:t>Add New → Project → Import Git Repository → shreenathacc22/ragcap. Authorise the Vercel GitHub app for this repo if asked.</a:t>
+              <a:t>Add New → Project → Import Git Repository → shreenathacc22/ragcap-m5. Authorise the Vercel GitHub app for this repo if asked.</a:t>
             </a:r>
             <a:endParaRPr lang="en-US" sz="1050" dirty="0"/>
           </a:p>
@@ -6018,7 +6018,7 @@
                   <a:schemeClr val="tx1"/>
                 </a:solidFill>
               </a:rPr>
-              <a:t>Settings → Domains → add ragcap.vercel.app (or any free name); paste the URL into README.md and the site, run publish_site.sh.</a:t>
+              <a:t>Settings → Domains → add ragcap-m5.vercel.app (or any free name); paste the URL into README.md and the site, run publish_site.sh.</a:t>
             </a:r>
             <a:endParaRPr lang="en-US" sz="1050" dirty="0"/>
           </a:p>
@@ -6336,7 +6336,7 @@
                 <a:ea typeface="Courier New" pitchFamily="34" charset="-122"/>
                 <a:cs typeface="Courier New" pitchFamily="34" charset="-120"/>
               </a:rPr>
-              <a:t>git clone https://github.com/shreenathacc22/ragcap &amp;&amp; cd ragcap</a:t>
+              <a:t>git clone https://github.com/shreenathacc22/ragcap-m5 &amp;&amp; cd ragcap-m5</a:t>
             </a:r>
             <a:endParaRPr lang="en-US" sz="1100" dirty="0"/>
           </a:p>
@@ -7250,7 +7250,7 @@
                   </a:extLst>
                 </a:hlinkClick>
               </a:rPr>
-              <a:t>https://github.com/shreenathacc22/ragcap</a:t>
+              <a:t>https://github.com/shreenathacc22/ragcap-m5</a:t>
             </a:r>
             <a:pPr indent="0" marL="0">
               <a:buNone/>
@@ -7279,7 +7279,7 @@
                   </a:extLst>
                 </a:hlinkClick>
               </a:rPr>
-              <a:t>https://shreenathacc22.github.io/ragcap/</a:t>
+              <a:t>https://shreenathacc22.github.io/ragcap-m5/</a:t>
             </a:r>
             <a:endParaRPr lang="en-US" sz="1200" dirty="0"/>
           </a:p>

</xml_diff>